<commit_message>
S8: make the idea-evaluation defence slides bilingual Chinese-English.
Co-authored-by: Cursor <cursoragent@cursor.com>
</commit_message>
<xml_diff>
--- a/my_work/idea_evaluation_defence.pptx
+++ b/my_work/idea_evaluation_defence.pptx
@@ -1796,17 +1796,41 @@
           <a:lstStyle/>
           <a:p>
             <a:pPr algn="l" indent="0" marL="0">
+              <a:spcAft>
+                <a:spcPts val="800"/>
+              </a:spcAft>
               <a:buNone/>
             </a:pPr>
             <a:r>
-              <a:rPr lang="en-US" sz="4400" b="1" dirty="0">
-                <a:solidFill>
-                  <a:schemeClr val="bg1"/>
-                </a:solidFill>
-              </a:rPr>
-              <a:t>海棠经纬——面向数字制造的参数化竹编扇生成系统 / Haitang Jingwei: A Parametric Bamboo-Fan Generator for Digital Fabrication</a:t>
+              <a:rPr sz="2400" b="1">
+                <a:solidFill>
+                  <a:srgbClr val="1A1A1A"/>
+                </a:solidFill>
+                <a:latin typeface="Calibri"/>
+                <a:ea typeface="Microsoft YaHei"/>
+                <a:cs typeface="Calibri"/>
+              </a:rPr>
+              <a:t>海棠经纬——面向数字制造的参数化竹编扇生成系统</a:t>
             </a:r>
             <a:endParaRPr lang="en-US" sz="4400" dirty="0"/>
+          </a:p>
+          <a:p>
+            <a:pPr algn="l">
+              <a:spcAft>
+                <a:spcPts val="0"/>
+              </a:spcAft>
+            </a:pPr>
+            <a:r>
+              <a:rPr sz="1600" b="0">
+                <a:solidFill>
+                  <a:srgbClr val="555555"/>
+                </a:solidFill>
+                <a:latin typeface="Calibri"/>
+                <a:ea typeface="Microsoft YaHei"/>
+                <a:cs typeface="Calibri"/>
+              </a:rPr>
+              <a:t>Haitang Jingwei: A Parametric Bamboo-Fan Generator for Digital Fabrication</a:t>
+            </a:r>
           </a:p>
         </p:txBody>
       </p:sp>
@@ -1834,31 +1858,79 @@
           <a:lstStyle/>
           <a:p>
             <a:pPr algn="l" indent="0" marL="0">
+              <a:spcAft>
+                <a:spcPts val="400"/>
+              </a:spcAft>
               <a:buNone/>
             </a:pPr>
             <a:r>
-              <a:rPr lang="en-US" sz="2200" dirty="0">
-                <a:solidFill>
-                  <a:schemeClr val="accent4"/>
-                </a:solidFill>
-              </a:rPr>
-              <a:t>汪俏黎 / WANG QIALI</a:t>
+              <a:rPr sz="2200" b="0">
+                <a:solidFill>
+                  <a:srgbClr val="1A1A1A"/>
+                </a:solidFill>
+                <a:latin typeface="Calibri"/>
+                <a:ea typeface="Microsoft YaHei"/>
+                <a:cs typeface="Calibri"/>
+              </a:rPr>
+              <a:t>汪俏黎</a:t>
             </a:r>
             <a:endParaRPr lang="en-US" sz="2200" dirty="0"/>
           </a:p>
           <a:p>
             <a:pPr algn="l" indent="0" marL="0">
+              <a:spcAft>
+                <a:spcPts val="1000"/>
+              </a:spcAft>
               <a:buNone/>
             </a:pPr>
             <a:r>
-              <a:rPr lang="en-US" sz="1800" dirty="0">
-                <a:solidFill>
-                  <a:schemeClr val="accent3"/>
-                </a:solidFill>
-              </a:rPr>
-              <a:t>个人项目 / Individual project</a:t>
+              <a:rPr sz="1800" b="0">
+                <a:solidFill>
+                  <a:srgbClr val="555555"/>
+                </a:solidFill>
+                <a:latin typeface="Calibri"/>
+                <a:ea typeface="Microsoft YaHei"/>
+                <a:cs typeface="Calibri"/>
+              </a:rPr>
+              <a:t>WANG QIALI</a:t>
             </a:r>
             <a:endParaRPr lang="en-US" sz="2200" dirty="0"/>
+          </a:p>
+          <a:p>
+            <a:pPr algn="l">
+              <a:spcAft>
+                <a:spcPts val="200"/>
+              </a:spcAft>
+            </a:pPr>
+            <a:r>
+              <a:rPr sz="1600" b="0">
+                <a:solidFill>
+                  <a:srgbClr val="1A1A1A"/>
+                </a:solidFill>
+                <a:latin typeface="Calibri"/>
+                <a:ea typeface="Microsoft YaHei"/>
+                <a:cs typeface="Calibri"/>
+              </a:rPr>
+              <a:t>个人项目</a:t>
+            </a:r>
+          </a:p>
+          <a:p>
+            <a:pPr algn="l">
+              <a:spcAft>
+                <a:spcPts val="0"/>
+              </a:spcAft>
+            </a:pPr>
+            <a:r>
+              <a:rPr sz="1400" b="0">
+                <a:solidFill>
+                  <a:srgbClr val="555555"/>
+                </a:solidFill>
+                <a:latin typeface="Calibri"/>
+                <a:ea typeface="Microsoft YaHei"/>
+                <a:cs typeface="Calibri"/>
+              </a:rPr>
+              <a:t>Individual project</a:t>
+            </a:r>
           </a:p>
         </p:txBody>
       </p:sp>
@@ -1911,15 +1983,21 @@
           <a:lstStyle/>
           <a:p>
             <a:pPr algn="l" indent="0" marL="0">
+              <a:spcAft>
+                <a:spcPts val="0"/>
+              </a:spcAft>
               <a:buNone/>
             </a:pPr>
             <a:r>
-              <a:rPr lang="en-US" sz="3200" b="1" dirty="0">
-                <a:solidFill>
-                  <a:schemeClr val="tx1"/>
-                </a:solidFill>
-              </a:rPr>
-              <a:t>The problem</a:t>
+              <a:rPr sz="2800" b="1">
+                <a:solidFill>
+                  <a:srgbClr val="1A1A1A"/>
+                </a:solidFill>
+                <a:latin typeface="Calibri"/>
+                <a:ea typeface="Microsoft YaHei"/>
+                <a:cs typeface="Calibri"/>
+              </a:rPr>
+              <a:t>问题 / The problem</a:t>
             </a:r>
             <a:endParaRPr lang="en-US" sz="3200" dirty="0"/>
           </a:p>
@@ -1949,17 +2027,113 @@
           <a:lstStyle/>
           <a:p>
             <a:pPr algn="l" indent="0" marL="0">
+              <a:spcAft>
+                <a:spcPts val="200"/>
+              </a:spcAft>
               <a:buNone/>
             </a:pPr>
             <a:r>
-              <a:rPr lang="en-US" sz="2200" dirty="0">
-                <a:solidFill>
-                  <a:schemeClr val="tx1"/>
-                </a:solidFill>
-              </a:rPr>
-              <a:t>非凸海棠硬边框内要连续编织、两端进框、无碎线。生成时就要满足桌面 3D 打印的线宽、间隙和悬垂。收进非专业用户能拖的 Web 系统，导出可切片网格。</a:t>
+              <a:rPr sz="1500" b="0">
+                <a:solidFill>
+                  <a:srgbClr val="1A1A1A"/>
+                </a:solidFill>
+                <a:latin typeface="Calibri"/>
+                <a:ea typeface="Microsoft YaHei"/>
+                <a:cs typeface="Calibri"/>
+              </a:rPr>
+              <a:t>在海棠形非凸硬边框内生成连续编织：压一挑一、两端进框、没有悬空碎线。</a:t>
             </a:r>
             <a:endParaRPr lang="en-US" sz="2200" dirty="0"/>
+          </a:p>
+          <a:p>
+            <a:pPr algn="l">
+              <a:spcAft>
+                <a:spcPts val="800"/>
+              </a:spcAft>
+            </a:pPr>
+            <a:r>
+              <a:rPr sz="1200" b="0">
+                <a:solidFill>
+                  <a:srgbClr val="555555"/>
+                </a:solidFill>
+                <a:latin typeface="Calibri"/>
+                <a:ea typeface="Microsoft YaHei"/>
+                <a:cs typeface="Calibri"/>
+              </a:rPr>
+              <a:t>Generate a continuous weave inside a non-convex haitang frame: over-under, ends in the rim, no dangling fragments.</a:t>
+            </a:r>
+          </a:p>
+          <a:p>
+            <a:pPr algn="l">
+              <a:spcAft>
+                <a:spcPts val="200"/>
+              </a:spcAft>
+            </a:pPr>
+            <a:r>
+              <a:rPr sz="1500" b="0">
+                <a:solidFill>
+                  <a:srgbClr val="1A1A1A"/>
+                </a:solidFill>
+                <a:latin typeface="Calibri"/>
+                <a:ea typeface="Microsoft YaHei"/>
+                <a:cs typeface="Calibri"/>
+              </a:rPr>
+              <a:t>生成时就要满足桌面 3D 打印的最小线宽、间隙和悬垂，而不是先出漂亮网格再在切片器里失败。</a:t>
+            </a:r>
+          </a:p>
+          <a:p>
+            <a:pPr algn="l">
+              <a:spcAft>
+                <a:spcPts val="800"/>
+              </a:spcAft>
+            </a:pPr>
+            <a:r>
+              <a:rPr sz="1200" b="0">
+                <a:solidFill>
+                  <a:srgbClr val="555555"/>
+                </a:solidFill>
+                <a:latin typeface="Calibri"/>
+                <a:ea typeface="Microsoft YaHei"/>
+                <a:cs typeface="Calibri"/>
+              </a:rPr>
+              <a:t>Print constraints (width, clearance, overhang) belong in generation, not after a pretty mesh fails in the slicer.</a:t>
+            </a:r>
+          </a:p>
+          <a:p>
+            <a:pPr algn="l">
+              <a:spcAft>
+                <a:spcPts val="200"/>
+              </a:spcAft>
+            </a:pPr>
+            <a:r>
+              <a:rPr sz="1500" b="0">
+                <a:solidFill>
+                  <a:srgbClr val="1A1A1A"/>
+                </a:solidFill>
+                <a:latin typeface="Calibri"/>
+                <a:ea typeface="Microsoft YaHei"/>
+                <a:cs typeface="Calibri"/>
+              </a:rPr>
+              <a:t>收进非专业用户能拖滑块的网页系统，导出可进入切片软件的网格。</a:t>
+            </a:r>
+          </a:p>
+          <a:p>
+            <a:pPr algn="l">
+              <a:spcAft>
+                <a:spcPts val="0"/>
+              </a:spcAft>
+            </a:pPr>
+            <a:r>
+              <a:rPr sz="1200" b="0">
+                <a:solidFill>
+                  <a:srgbClr val="555555"/>
+                </a:solidFill>
+                <a:latin typeface="Calibri"/>
+                <a:ea typeface="Microsoft YaHei"/>
+                <a:cs typeface="Calibri"/>
+              </a:rPr>
+              <a:t>A non-expert web tool with sliders, exporting a mesh that can go to the slicer.</a:t>
+            </a:r>
           </a:p>
         </p:txBody>
       </p:sp>
@@ -1984,19 +2158,22 @@
           <a:bodyPr wrap="square" lIns="0" tIns="0" rIns="0" bIns="0" rtlCol="0" anchor="ctr"/>
           <a:lstStyle/>
           <a:p>
-            <a:pPr indent="0" marL="0">
+            <a:pPr indent="0" marL="0" algn="l">
+              <a:spcAft>
+                <a:spcPts val="0"/>
+              </a:spcAft>
               <a:buNone/>
             </a:pPr>
             <a:r>
-              <a:rPr lang="en-US" sz="1800" b="1" dirty="0">
-                <a:solidFill>
-                  <a:schemeClr val="tx1"/>
-                </a:solidFill>
-                <a:latin typeface="+mj-lt" pitchFamily="34" charset="0"/>
-                <a:ea typeface="+mj-lt" pitchFamily="34" charset="-122"/>
-                <a:cs typeface="+mj-lt" pitchFamily="34" charset="-120"/>
-              </a:rPr>
-              <a:t>New or old?</a:t>
+              <a:rPr sz="1600" b="1">
+                <a:solidFill>
+                  <a:srgbClr val="1A1A1A"/>
+                </a:solidFill>
+                <a:latin typeface="Calibri"/>
+                <a:ea typeface="Microsoft YaHei"/>
+                <a:cs typeface="Calibri"/>
+              </a:rPr>
+              <a:t>新或旧？ / New or old?</a:t>
             </a:r>
             <a:endParaRPr lang="en-US" sz="1800" dirty="0"/>
           </a:p>
@@ -2026,17 +2203,77 @@
           <a:lstStyle/>
           <a:p>
             <a:pPr algn="l" indent="0" marL="0">
+              <a:spcAft>
+                <a:spcPts val="400"/>
+              </a:spcAft>
               <a:buNone/>
             </a:pPr>
             <a:r>
-              <a:rPr lang="en-US" sz="1800" dirty="0">
-                <a:solidFill>
-                  <a:schemeClr val="tx1"/>
-                </a:solidFill>
-              </a:rPr>
-              <a:t>旧问题。Ren/Panetta、Wu 的织机折返、Weavecraft、Muslimin 语法、Wang 的机器人竹亭都做过编织；它们都不处理这把扇的闭合硬框加打印约束。</a:t>
+              <a:rPr sz="1300" b="0">
+                <a:solidFill>
+                  <a:srgbClr val="1A1A1A"/>
+                </a:solidFill>
+                <a:latin typeface="Calibri"/>
+                <a:ea typeface="Microsoft YaHei"/>
+                <a:cs typeface="Calibri"/>
+              </a:rPr>
+              <a:t>旧问题。Ren/Panetta、Wu 的织机折返、Weavecraft、Muslimin 语法、Wang 的机器人竹亭都做过编织。</a:t>
             </a:r>
             <a:endParaRPr lang="en-US" sz="1800" dirty="0"/>
+          </a:p>
+          <a:p>
+            <a:pPr algn="l">
+              <a:spcAft>
+                <a:spcPts val="800"/>
+              </a:spcAft>
+            </a:pPr>
+            <a:r>
+              <a:rPr sz="1100" b="0">
+                <a:solidFill>
+                  <a:srgbClr val="555555"/>
+                </a:solidFill>
+                <a:latin typeface="Calibri"/>
+                <a:ea typeface="Microsoft YaHei"/>
+                <a:cs typeface="Calibri"/>
+              </a:rPr>
+              <a:t>An old problem. Computational weaving already exists in those five works.</a:t>
+            </a:r>
+          </a:p>
+          <a:p>
+            <a:pPr algn="l">
+              <a:spcAft>
+                <a:spcPts val="400"/>
+              </a:spcAft>
+            </a:pPr>
+            <a:r>
+              <a:rPr sz="1300" b="0">
+                <a:solidFill>
+                  <a:srgbClr val="1A1A1A"/>
+                </a:solidFill>
+                <a:latin typeface="Calibri"/>
+                <a:ea typeface="Microsoft YaHei"/>
+                <a:cs typeface="Calibri"/>
+              </a:rPr>
+              <a:t>它们都不处理这把扇的闭合硬框，加上桌面 3D 打印必须一次打出的刚性几何。</a:t>
+            </a:r>
+          </a:p>
+          <a:p>
+            <a:pPr algn="l">
+              <a:spcAft>
+                <a:spcPts val="0"/>
+              </a:spcAft>
+            </a:pPr>
+            <a:r>
+              <a:rPr sz="1100" b="0">
+                <a:solidFill>
+                  <a:srgbClr val="555555"/>
+                </a:solidFill>
+                <a:latin typeface="Calibri"/>
+                <a:ea typeface="Microsoft YaHei"/>
+                <a:cs typeface="Calibri"/>
+              </a:rPr>
+              <a:t>None of them handle this closed rigid frame plus one-shot desktop 3D-print geometry.</a:t>
+            </a:r>
           </a:p>
         </p:txBody>
       </p:sp>
@@ -2134,15 +2371,21 @@
           <a:lstStyle/>
           <a:p>
             <a:pPr algn="l" indent="0" marL="0">
+              <a:spcAft>
+                <a:spcPts val="0"/>
+              </a:spcAft>
               <a:buNone/>
             </a:pPr>
             <a:r>
-              <a:rPr lang="en-US" sz="3200" b="1" dirty="0">
-                <a:solidFill>
-                  <a:schemeClr val="tx1"/>
-                </a:solidFill>
-              </a:rPr>
-              <a:t>The gap</a:t>
+              <a:rPr sz="2800" b="1">
+                <a:solidFill>
+                  <a:srgbClr val="1A1A1A"/>
+                </a:solidFill>
+                <a:latin typeface="Calibri"/>
+                <a:ea typeface="Microsoft YaHei"/>
+                <a:cs typeface="Calibri"/>
+              </a:rPr>
+              <a:t>缺口 / The gap</a:t>
             </a:r>
             <a:endParaRPr lang="en-US" sz="3200" dirty="0"/>
           </a:p>
@@ -2172,48 +2415,120 @@
           <a:lstStyle/>
           <a:p>
             <a:pPr algn="l" marL="342900" indent="-342900">
+              <a:spcAft>
+                <a:spcPts val="200"/>
+              </a:spcAft>
               <a:buSzPct val="100000"/>
               <a:buChar char="•"/>
             </a:pPr>
             <a:r>
-              <a:rPr lang="en-US" sz="2200" dirty="0">
-                <a:solidFill>
-                  <a:schemeClr val="tx1"/>
-                </a:solidFill>
-              </a:rPr>
-              <a:t>Ren, Panetta et al. 2021：曲面弹性条带，不处理闭合硬框，也不能实时、不能直接 3D 打印。</a:t>
+              <a:rPr sz="1300" b="0">
+                <a:solidFill>
+                  <a:srgbClr val="1A1A1A"/>
+                </a:solidFill>
+                <a:latin typeface="Calibri"/>
+                <a:ea typeface="Microsoft YaHei"/>
+                <a:cs typeface="Calibri"/>
+              </a:rPr>
+              <a:t>Ren, Panetta 等，2021：弯曲弹性条带能铺曲面，但不处理闭合硬框，也不能实时、不能直接 3D 打印。</a:t>
             </a:r>
             <a:endParaRPr lang="en-US" sz="2200" dirty="0"/>
           </a:p>
           <a:p>
             <a:pPr algn="l" marL="342900" indent="-342900">
+              <a:spcAft>
+                <a:spcPts val="800"/>
+              </a:spcAft>
               <a:buSzPct val="100000"/>
               <a:buChar char="•"/>
             </a:pPr>
             <a:r>
-              <a:rPr lang="en-US" sz="2200" dirty="0">
-                <a:solidFill>
-                  <a:schemeClr val="tx1"/>
-                </a:solidFill>
-              </a:rPr>
-              <a:t>Wu et al. 2020 织机浮雕：矩形布边折返，迁不到海棠框。</a:t>
+              <a:rPr sz="1100" b="0">
+                <a:solidFill>
+                  <a:srgbClr val="555555"/>
+                </a:solidFill>
+                <a:latin typeface="Calibri"/>
+                <a:ea typeface="Microsoft YaHei"/>
+                <a:cs typeface="Calibri"/>
+              </a:rPr>
+              <a:t>Ren, Panetta et al. 2021: curved elastic ribbons on freeform surfaces — no closed rigid frame, not real-time, not a printable solid.</a:t>
             </a:r>
             <a:endParaRPr lang="en-US" sz="2200" dirty="0"/>
           </a:p>
           <a:p>
             <a:pPr algn="l" marL="342900" indent="-342900">
+              <a:spcAft>
+                <a:spcPts val="200"/>
+              </a:spcAft>
               <a:buSzPct val="100000"/>
               <a:buChar char="•"/>
             </a:pPr>
             <a:r>
-              <a:rPr lang="en-US" sz="2200" dirty="0">
-                <a:solidFill>
-                  <a:schemeClr val="tx1"/>
-                </a:solidFill>
-              </a:rPr>
-              <a:t>Weavecraft 2020：仿真界面成熟，没有带框的可打印实体。</a:t>
+              <a:rPr sz="1300" b="0">
+                <a:solidFill>
+                  <a:srgbClr val="1A1A1A"/>
+                </a:solidFill>
+                <a:latin typeface="Calibri"/>
+                <a:ea typeface="Microsoft YaHei"/>
+                <a:cs typeface="Calibri"/>
+              </a:rPr>
+              <a:t>Wu 等，2020 织机浮雕：矩形布边折返保证连续，迁不到海棠形硬框。</a:t>
             </a:r>
             <a:endParaRPr lang="en-US" sz="2200" dirty="0"/>
+          </a:p>
+          <a:p>
+            <a:pPr algn="l">
+              <a:spcAft>
+                <a:spcPts val="800"/>
+              </a:spcAft>
+            </a:pPr>
+            <a:r>
+              <a:rPr sz="1100" b="0">
+                <a:solidFill>
+                  <a:srgbClr val="555555"/>
+                </a:solidFill>
+                <a:latin typeface="Calibri"/>
+                <a:ea typeface="Microsoft YaHei"/>
+                <a:cs typeface="Calibri"/>
+              </a:rPr>
+              <a:t>Wu et al. 2020 woven relief: continuous return on a rectangular loom edge — it does not transfer to a haitang rim.</a:t>
+            </a:r>
+          </a:p>
+          <a:p>
+            <a:pPr algn="l">
+              <a:spcAft>
+                <a:spcPts val="200"/>
+              </a:spcAft>
+            </a:pPr>
+            <a:r>
+              <a:rPr sz="1300" b="0">
+                <a:solidFill>
+                  <a:srgbClr val="1A1A1A"/>
+                </a:solidFill>
+                <a:latin typeface="Calibri"/>
+                <a:ea typeface="Microsoft YaHei"/>
+                <a:cs typeface="Calibri"/>
+              </a:rPr>
+              <a:t>Weavecraft，2020：非专家仿真界面成熟，没有带框的可打印实体。</a:t>
+            </a:r>
+          </a:p>
+          <a:p>
+            <a:pPr algn="l">
+              <a:spcAft>
+                <a:spcPts val="0"/>
+              </a:spcAft>
+            </a:pPr>
+            <a:r>
+              <a:rPr sz="1100" b="0">
+                <a:solidFill>
+                  <a:srgbClr val="555555"/>
+                </a:solidFill>
+                <a:latin typeface="Calibri"/>
+                <a:ea typeface="Microsoft YaHei"/>
+                <a:cs typeface="Calibri"/>
+              </a:rPr>
+              <a:t>Weavecraft 2020: a mature simulation UI, not a framed, printable object.</a:t>
+            </a:r>
           </a:p>
         </p:txBody>
       </p:sp>
@@ -2238,19 +2553,22 @@
           <a:bodyPr wrap="square" lIns="0" tIns="0" rIns="0" bIns="0" rtlCol="0" anchor="ctr"/>
           <a:lstStyle/>
           <a:p>
-            <a:pPr indent="0" marL="0">
+            <a:pPr indent="0" marL="0" algn="l">
+              <a:spcAft>
+                <a:spcPts val="0"/>
+              </a:spcAft>
               <a:buNone/>
             </a:pPr>
             <a:r>
-              <a:rPr lang="en-US" sz="1800" b="1" dirty="0">
-                <a:solidFill>
-                  <a:schemeClr val="tx1"/>
-                </a:solidFill>
-                <a:latin typeface="+mj-lt" pitchFamily="34" charset="0"/>
-                <a:ea typeface="+mj-lt" pitchFamily="34" charset="-122"/>
-                <a:cs typeface="+mj-lt" pitchFamily="34" charset="-120"/>
-              </a:rPr>
-              <a:t>The gap, and what changed</a:t>
+              <a:rPr sz="1300" b="1">
+                <a:solidFill>
+                  <a:srgbClr val="1A1A1A"/>
+                </a:solidFill>
+                <a:latin typeface="Calibri"/>
+                <a:ea typeface="Microsoft YaHei"/>
+                <a:cs typeface="Calibri"/>
+              </a:rPr>
+              <a:t>缺口，以及改了什么 / The gap, and what changed</a:t>
             </a:r>
             <a:endParaRPr lang="en-US" sz="1800" dirty="0"/>
           </a:p>
@@ -2280,37 +2598,81 @@
           <a:lstStyle/>
           <a:p>
             <a:pPr algn="l" indent="0" marL="0">
+              <a:spcAft>
+                <a:spcPts val="400"/>
+              </a:spcAft>
               <a:buNone/>
             </a:pPr>
             <a:r>
-              <a:rPr lang="en-US" sz="1800" b="1" dirty="0">
-                <a:solidFill>
-                  <a:schemeClr val="tx1"/>
-                </a:solidFill>
-              </a:rPr>
-              <a:t>现有计算编织系统缺乏面向非凸封闭边界的几何锚定算法，无法实时生成无碎线、具真实起伏且匹配 3D 打印约束的连续竹编结构。</a:t>
+              <a:rPr sz="1300" b="1">
+                <a:solidFill>
+                  <a:srgbClr val="1A1A1A"/>
+                </a:solidFill>
+                <a:latin typeface="Calibri"/>
+                <a:ea typeface="Microsoft YaHei"/>
+                <a:cs typeface="Calibri"/>
+              </a:rPr>
+              <a:t>现有计算编织缺少面向非凸封闭边界的几何锚定，无法实时生成无碎线、有起伏、且匹配 3D 打印约束的连续竹编。</a:t>
             </a:r>
             <a:endParaRPr lang="en-US" sz="1800" dirty="0"/>
           </a:p>
           <a:p>
             <a:pPr algn="l" indent="0" marL="0">
+              <a:spcAft>
+                <a:spcPts val="1000"/>
+              </a:spcAft>
               <a:buNone/>
             </a:pPr>
+            <a:r>
+              <a:rPr sz="1100" b="0">
+                <a:solidFill>
+                  <a:srgbClr val="555555"/>
+                </a:solidFill>
+                <a:latin typeface="Calibri"/>
+                <a:ea typeface="Microsoft YaHei"/>
+                <a:cs typeface="Calibri"/>
+              </a:rPr>
+              <a:t>Current computational weaving lacks geometric anchoring to a non-convex closed boundary, so it cannot live-generate a continuous bamboo weave with no fragments, real relief, and print constraints.</a:t>
+            </a:r>
             <a:endParaRPr lang="en-US" sz="1800" dirty="0"/>
           </a:p>
           <a:p>
             <a:pPr algn="l" indent="0" marL="0">
+              <a:spcAft>
+                <a:spcPts val="400"/>
+              </a:spcAft>
               <a:buNone/>
             </a:pPr>
             <a:r>
-              <a:rPr lang="en-US" sz="1800" dirty="0">
-                <a:solidFill>
-                  <a:schemeClr val="tx1"/>
-                </a:solidFill>
-              </a:rPr>
-              <a:t>废弃布尔裁剪；把打印间隙/悬垂写进生成；只声称几何转译；本学期不做用户实验。</a:t>
+              <a:rPr sz="1300" b="0">
+                <a:solidFill>
+                  <a:srgbClr val="1A1A1A"/>
+                </a:solidFill>
+                <a:latin typeface="Calibri"/>
+                <a:ea typeface="Microsoft YaHei"/>
+                <a:cs typeface="Calibri"/>
+              </a:rPr>
+              <a:t>因此：废弃布尔裁剪；把间隙和悬垂写进生成；只声称几何转译；本学期不做用户实验。</a:t>
             </a:r>
             <a:endParaRPr lang="en-US" sz="1800" dirty="0"/>
+          </a:p>
+          <a:p>
+            <a:pPr algn="l">
+              <a:spcAft>
+                <a:spcPts val="0"/>
+              </a:spcAft>
+            </a:pPr>
+            <a:r>
+              <a:rPr sz="1100" b="0">
+                <a:solidFill>
+                  <a:srgbClr val="555555"/>
+                </a:solidFill>
+                <a:latin typeface="Calibri"/>
+                <a:ea typeface="Microsoft YaHei"/>
+                <a:cs typeface="Calibri"/>
+              </a:rPr>
+              <a:t>So: drop Boolean trim; put clearance and overhang in the generator; claim geometric translation only; no user study this term.</a:t>
+            </a:r>
           </a:p>
         </p:txBody>
       </p:sp>
@@ -2408,15 +2770,21 @@
           <a:lstStyle/>
           <a:p>
             <a:pPr algn="l" indent="0" marL="0">
+              <a:spcAft>
+                <a:spcPts val="0"/>
+              </a:spcAft>
               <a:buNone/>
             </a:pPr>
             <a:r>
-              <a:rPr lang="en-US" sz="3200" b="1" dirty="0">
-                <a:solidFill>
-                  <a:schemeClr val="tx1"/>
-                </a:solidFill>
-              </a:rPr>
-              <a:t>The contribution</a:t>
+              <a:rPr sz="2800" b="1">
+                <a:solidFill>
+                  <a:srgbClr val="1A1A1A"/>
+                </a:solidFill>
+                <a:latin typeface="Calibri"/>
+                <a:ea typeface="Microsoft YaHei"/>
+                <a:cs typeface="Calibri"/>
+              </a:rPr>
+              <a:t>贡献 / The contribution</a:t>
             </a:r>
             <a:endParaRPr lang="en-US" sz="3200" dirty="0"/>
           </a:p>
@@ -2446,62 +2814,158 @@
           <a:lstStyle/>
           <a:p>
             <a:pPr algn="l" indent="0" marL="0">
+              <a:spcAft>
+                <a:spcPts val="200"/>
+              </a:spcAft>
               <a:buNone/>
             </a:pPr>
             <a:r>
-              <a:rPr lang="en-US" sz="2200" b="1" dirty="0">
-                <a:solidFill>
-                  <a:schemeClr val="tx1"/>
-                </a:solidFill>
-              </a:rPr>
-              <a:t>Type: method / 方法贡献</a:t>
+              <a:rPr sz="1600" b="1">
+                <a:solidFill>
+                  <a:srgbClr val="1A1A1A"/>
+                </a:solidFill>
+                <a:latin typeface="Calibri"/>
+                <a:ea typeface="Microsoft YaHei"/>
+                <a:cs typeface="Calibri"/>
+              </a:rPr>
+              <a:t>类型：方法贡献</a:t>
             </a:r>
             <a:endParaRPr lang="en-US" sz="2200" dirty="0"/>
           </a:p>
           <a:p>
             <a:pPr algn="l" marL="342900" indent="-342900">
+              <a:spcAft>
+                <a:spcPts val="800"/>
+              </a:spcAft>
               <a:buSzPct val="100000"/>
               <a:buChar char="•"/>
             </a:pPr>
             <a:r>
-              <a:rPr lang="en-US" sz="2200" dirty="0">
-                <a:solidFill>
-                  <a:schemeClr val="tx1"/>
-                </a:solidFill>
-              </a:rPr>
-              <a:t>1 边界碎线 → 求交、去短线、端点嵌入边框 → 瓣角仍连续可打印</a:t>
+              <a:rPr sz="1300" b="1">
+                <a:solidFill>
+                  <a:srgbClr val="555555"/>
+                </a:solidFill>
+                <a:latin typeface="Calibri"/>
+                <a:ea typeface="Microsoft YaHei"/>
+                <a:cs typeface="Calibri"/>
+              </a:rPr>
+              <a:t>Type: method contribution</a:t>
             </a:r>
             <a:endParaRPr lang="en-US" sz="2200" dirty="0"/>
           </a:p>
           <a:p>
             <a:pPr algn="l" marL="342900" indent="-342900">
+              <a:spcAft>
+                <a:spcPts val="200"/>
+              </a:spcAft>
               <a:buSzPct val="100000"/>
               <a:buChar char="•"/>
             </a:pPr>
             <a:r>
-              <a:rPr lang="en-US" sz="2200" dirty="0">
-                <a:solidFill>
-                  <a:schemeClr val="tx1"/>
-                </a:solidFill>
-              </a:rPr>
-              <a:t>2 过密即穿模 → 压挑+间隙+悬垂锁死 → 导出与打印机公差一致</a:t>
+              <a:rPr sz="1300" b="0">
+                <a:solidFill>
+                  <a:srgbClr val="1A1A1A"/>
+                </a:solidFill>
+                <a:latin typeface="Calibri"/>
+                <a:ea typeface="Microsoft YaHei"/>
+                <a:cs typeface="Calibri"/>
+              </a:rPr>
+              <a:t>1 边界碎线 → 求交、去短线、端点嵌入边框 → 瓣角仍连续可打印</a:t>
             </a:r>
             <a:endParaRPr lang="en-US" sz="2200" dirty="0"/>
           </a:p>
           <a:p>
             <a:pPr algn="l" marL="342900" indent="-342900">
+              <a:spcAft>
+                <a:spcPts val="600"/>
+              </a:spcAft>
               <a:buSzPct val="100000"/>
               <a:buChar char="•"/>
             </a:pPr>
             <a:r>
-              <a:rPr lang="en-US" sz="2200" dirty="0">
-                <a:solidFill>
-                  <a:schemeClr val="tx1"/>
-                </a:solidFill>
-              </a:rPr>
-              <a:t>3 工具停在仿真 → Web 滑块到 STL（辅助证据，不是主贡献）</a:t>
+              <a:rPr sz="1100" b="0">
+                <a:solidFill>
+                  <a:srgbClr val="555555"/>
+                </a:solidFill>
+                <a:latin typeface="Calibri"/>
+                <a:ea typeface="Microsoft YaHei"/>
+                <a:cs typeface="Calibri"/>
+              </a:rPr>
+              <a:t>1 Fragments at the rim → intersect, drop shorts, embed ends → the petals stay continuous and printable.</a:t>
             </a:r>
             <a:endParaRPr lang="en-US" sz="2200" dirty="0"/>
+          </a:p>
+          <a:p>
+            <a:pPr algn="l">
+              <a:spcAft>
+                <a:spcPts val="200"/>
+              </a:spcAft>
+            </a:pPr>
+            <a:r>
+              <a:rPr sz="1300" b="0">
+                <a:solidFill>
+                  <a:srgbClr val="1A1A1A"/>
+                </a:solidFill>
+                <a:latin typeface="Calibri"/>
+                <a:ea typeface="Microsoft YaHei"/>
+                <a:cs typeface="Calibri"/>
+              </a:rPr>
+              <a:t>2 过密即穿模 → 压挑、间隙、悬垂锁死 → 导出与打印机公差一致</a:t>
+            </a:r>
+          </a:p>
+          <a:p>
+            <a:pPr algn="l">
+              <a:spcAft>
+                <a:spcPts val="600"/>
+              </a:spcAft>
+            </a:pPr>
+            <a:r>
+              <a:rPr sz="1100" b="0">
+                <a:solidFill>
+                  <a:srgbClr val="555555"/>
+                </a:solidFill>
+                <a:latin typeface="Calibri"/>
+                <a:ea typeface="Microsoft YaHei"/>
+                <a:cs typeface="Calibri"/>
+              </a:rPr>
+              <a:t>2 Density causes collisions → over-under, clearance, overhang locks → export matches printer tolerance.</a:t>
+            </a:r>
+          </a:p>
+          <a:p>
+            <a:pPr algn="l">
+              <a:spcAft>
+                <a:spcPts val="200"/>
+              </a:spcAft>
+            </a:pPr>
+            <a:r>
+              <a:rPr sz="1300" b="0">
+                <a:solidFill>
+                  <a:srgbClr val="1A1A1A"/>
+                </a:solidFill>
+                <a:latin typeface="Calibri"/>
+                <a:ea typeface="Microsoft YaHei"/>
+                <a:cs typeface="Calibri"/>
+              </a:rPr>
+              <a:t>3 工具停在仿真 → 网页滑块到 STL（辅助证据，不是主贡献）</a:t>
+            </a:r>
+          </a:p>
+          <a:p>
+            <a:pPr algn="l">
+              <a:spcAft>
+                <a:spcPts val="0"/>
+              </a:spcAft>
+            </a:pPr>
+            <a:r>
+              <a:rPr sz="1100" b="0">
+                <a:solidFill>
+                  <a:srgbClr val="555555"/>
+                </a:solidFill>
+                <a:latin typeface="Calibri"/>
+                <a:ea typeface="Microsoft YaHei"/>
+                <a:cs typeface="Calibri"/>
+              </a:rPr>
+              <a:t>3 Tools stop at simulation → sliders to STL (supporting evidence, not the main claim).</a:t>
+            </a:r>
           </a:p>
         </p:txBody>
       </p:sp>
@@ -2526,19 +2990,22 @@
           <a:bodyPr wrap="square" lIns="0" tIns="0" rIns="0" bIns="0" rtlCol="0" anchor="ctr"/>
           <a:lstStyle/>
           <a:p>
-            <a:pPr indent="0" marL="0">
+            <a:pPr indent="0" marL="0" algn="l">
+              <a:spcAft>
+                <a:spcPts val="0"/>
+              </a:spcAft>
               <a:buNone/>
             </a:pPr>
             <a:r>
-              <a:rPr lang="en-US" sz="1800" b="1" dirty="0">
-                <a:solidFill>
-                  <a:schemeClr val="tx1"/>
-                </a:solidFill>
-                <a:latin typeface="+mj-lt" pitchFamily="34" charset="0"/>
-                <a:ea typeface="+mj-lt" pitchFamily="34" charset="-122"/>
-                <a:cs typeface="+mj-lt" pitchFamily="34" charset="-120"/>
-              </a:rPr>
-              <a:t>Necessity test</a:t>
+              <a:rPr sz="1400" b="1">
+                <a:solidFill>
+                  <a:srgbClr val="1A1A1A"/>
+                </a:solidFill>
+                <a:latin typeface="Calibri"/>
+                <a:ea typeface="Microsoft YaHei"/>
+                <a:cs typeface="Calibri"/>
+              </a:rPr>
+              <a:t>必要性测试 / Necessity test</a:t>
             </a:r>
             <a:endParaRPr lang="en-US" sz="1800" dirty="0"/>
           </a:p>
@@ -2568,37 +3035,81 @@
           <a:lstStyle/>
           <a:p>
             <a:pPr algn="l" indent="0" marL="0">
+              <a:spcAft>
+                <a:spcPts val="400"/>
+              </a:spcAft>
               <a:buNone/>
             </a:pPr>
             <a:r>
-              <a:rPr lang="en-US" sz="1800" dirty="0">
-                <a:solidFill>
-                  <a:schemeClr val="tx1"/>
-                </a:solidFill>
-              </a:rPr>
-              <a:t>不做：布尔断头能否打印，只有打印件能证明。现在还没有打印。</a:t>
+              <a:rPr sz="1300" b="0">
+                <a:solidFill>
+                  <a:srgbClr val="1A1A1A"/>
+                </a:solidFill>
+                <a:latin typeface="Calibri"/>
+                <a:ea typeface="Microsoft YaHei"/>
+                <a:cs typeface="Calibri"/>
+              </a:rPr>
+              <a:t>不做：布尔断头能不能打印，只有打印件能证明。现在还没有打印。</a:t>
             </a:r>
             <a:endParaRPr lang="en-US" sz="1800" dirty="0"/>
           </a:p>
           <a:p>
             <a:pPr algn="l" indent="0" marL="0">
+              <a:spcAft>
+                <a:spcPts val="1000"/>
+              </a:spcAft>
               <a:buNone/>
             </a:pPr>
+            <a:r>
+              <a:rPr sz="1100" b="0">
+                <a:solidFill>
+                  <a:srgbClr val="555555"/>
+                </a:solidFill>
+                <a:latin typeface="Calibri"/>
+                <a:ea typeface="Microsoft YaHei"/>
+                <a:cs typeface="Calibri"/>
+              </a:rPr>
+              <a:t>Without making: only prints can show whether Boolean stubs fail. Nothing has been printed yet.</a:t>
+            </a:r>
             <a:endParaRPr lang="en-US" sz="1800" dirty="0"/>
           </a:p>
           <a:p>
             <a:pPr algn="l" indent="0" marL="0">
+              <a:spcAft>
+                <a:spcPts val="400"/>
+              </a:spcAft>
               <a:buNone/>
             </a:pPr>
             <a:r>
-              <a:rPr lang="en-US" sz="1800" dirty="0">
-                <a:solidFill>
-                  <a:schemeClr val="tx1"/>
-                </a:solidFill>
-              </a:rPr>
-              <a:t>不在这里：去掉海棠硬框和桌面打印，就只剩已被做过的计算编织。</a:t>
+              <a:rPr sz="1300" b="0">
+                <a:solidFill>
+                  <a:srgbClr val="1A1A1A"/>
+                </a:solidFill>
+                <a:latin typeface="Calibri"/>
+                <a:ea typeface="Microsoft YaHei"/>
+                <a:cs typeface="Calibri"/>
+              </a:rPr>
+              <a:t>不在这里：去掉海棠硬框和桌面打印，就只剩别人已经做过的计算编织。</a:t>
             </a:r>
             <a:endParaRPr lang="en-US" sz="1800" dirty="0"/>
+          </a:p>
+          <a:p>
+            <a:pPr algn="l">
+              <a:spcAft>
+                <a:spcPts val="0"/>
+              </a:spcAft>
+            </a:pPr>
+            <a:r>
+              <a:rPr sz="1100" b="0">
+                <a:solidFill>
+                  <a:srgbClr val="555555"/>
+                </a:solidFill>
+                <a:latin typeface="Calibri"/>
+                <a:ea typeface="Microsoft YaHei"/>
+                <a:cs typeface="Calibri"/>
+              </a:rPr>
+              <a:t>Without this site: remove the haitang rim and desktop printing, and only prior computational weaving remains.</a:t>
+            </a:r>
           </a:p>
         </p:txBody>
       </p:sp>
@@ -2696,15 +3207,21 @@
           <a:lstStyle/>
           <a:p>
             <a:pPr algn="l" indent="0" marL="0">
+              <a:spcAft>
+                <a:spcPts val="0"/>
+              </a:spcAft>
               <a:buNone/>
             </a:pPr>
             <a:r>
-              <a:rPr lang="en-US" sz="3200" b="1" dirty="0">
-                <a:solidFill>
-                  <a:schemeClr val="tx1"/>
-                </a:solidFill>
-              </a:rPr>
-              <a:t>Where it goes, and what I will make</a:t>
+              <a:rPr sz="2000" b="1">
+                <a:solidFill>
+                  <a:srgbClr val="1A1A1A"/>
+                </a:solidFill>
+                <a:latin typeface="Calibri"/>
+                <a:ea typeface="Microsoft YaHei"/>
+                <a:cs typeface="Calibri"/>
+              </a:rPr>
+              <a:t>投哪里，以及我要做什么 / Where it goes, and what I will make</a:t>
             </a:r>
             <a:endParaRPr lang="en-US" sz="3200" dirty="0"/>
           </a:p>
@@ -2734,51 +3251,155 @@
           <a:lstStyle/>
           <a:p>
             <a:pPr algn="l" indent="0" marL="0">
+              <a:spcAft>
+                <a:spcPts val="200"/>
+              </a:spcAft>
               <a:buNone/>
             </a:pPr>
             <a:r>
-              <a:rPr lang="en-US" sz="2200" b="1" dirty="0">
-                <a:solidFill>
-                  <a:schemeClr val="tx1"/>
-                </a:solidFill>
-              </a:rPr>
-              <a:t>ACM DIS 2027 · Papers · ~7000-8000 words · abstract 11 Jan 2027 AoE / full paper 18 Jan 2027 AoE</a:t>
+              <a:rPr sz="1400" b="1">
+                <a:solidFill>
+                  <a:srgbClr val="1A1A1A"/>
+                </a:solidFill>
+                <a:latin typeface="Calibri"/>
+                <a:ea typeface="Microsoft YaHei"/>
+                <a:cs typeface="Calibri"/>
+              </a:rPr>
+              <a:t>主投：ACM DIS 2027 · Papers · 约 7,000–8,000 词</a:t>
             </a:r>
             <a:endParaRPr lang="en-US" sz="2200" dirty="0"/>
           </a:p>
           <a:p>
             <a:pPr algn="l" indent="0" marL="0">
+              <a:spcAft>
+                <a:spcPts val="600"/>
+              </a:spcAft>
               <a:buNone/>
             </a:pPr>
             <a:r>
-              <a:rPr lang="en-US" sz="2200" dirty="0">
-                <a:solidFill>
-                  <a:schemeClr val="tx1"/>
-                </a:solidFill>
-              </a:rPr>
-              <a:t>Reviewers ask: is the DIS/HCI contribution clear, is it situated in HCI, are the implications for interaction design stated?</a:t>
+              <a:rPr sz="1200" b="0">
+                <a:solidFill>
+                  <a:srgbClr val="555555"/>
+                </a:solidFill>
+                <a:latin typeface="Calibri"/>
+                <a:ea typeface="Microsoft YaHei"/>
+                <a:cs typeface="Calibri"/>
+              </a:rPr>
+              <a:t>Primary: ACM DIS 2027 · Papers · about 7,000–8,000 words</a:t>
             </a:r>
             <a:endParaRPr lang="en-US" sz="2200" dirty="0"/>
           </a:p>
           <a:p>
             <a:pPr algn="l" indent="0" marL="0">
+              <a:spcAft>
+                <a:spcPts val="200"/>
+              </a:spcAft>
               <a:buNone/>
             </a:pPr>
+            <a:r>
+              <a:rPr sz="1400" b="0">
+                <a:solidFill>
+                  <a:srgbClr val="1A1A1A"/>
+                </a:solidFill>
+                <a:latin typeface="Calibri"/>
+                <a:ea typeface="Microsoft YaHei"/>
+                <a:cs typeface="Calibri"/>
+              </a:rPr>
+              <a:t>摘要 2027年1月11日 AoE；全文 1月18日 AoE</a:t>
+            </a:r>
             <a:endParaRPr lang="en-US" sz="2200" dirty="0"/>
           </a:p>
           <a:p>
             <a:pPr algn="l" indent="0" marL="0">
+              <a:spcAft>
+                <a:spcPts val="800"/>
+              </a:spcAft>
               <a:buNone/>
             </a:pPr>
             <a:r>
-              <a:rPr lang="en-US" sz="2200" dirty="0">
-                <a:solidFill>
-                  <a:schemeClr val="tx1"/>
-                </a:solidFill>
-              </a:rPr>
-              <a:t>Backup: ACM C and C 2027 Papers · abstract 19 Jan / full 25 Jan 2027 AoE (TEI Arts not used)</a:t>
+              <a:rPr sz="1200" b="0">
+                <a:solidFill>
+                  <a:srgbClr val="555555"/>
+                </a:solidFill>
+                <a:latin typeface="Calibri"/>
+                <a:ea typeface="Microsoft YaHei"/>
+                <a:cs typeface="Calibri"/>
+              </a:rPr>
+              <a:t>Abstract 11 Jan 2027 AoE; full paper 18 Jan 2027 AoE</a:t>
             </a:r>
             <a:endParaRPr lang="en-US" sz="2200" dirty="0"/>
+          </a:p>
+          <a:p>
+            <a:pPr algn="l">
+              <a:spcAft>
+                <a:spcPts val="200"/>
+              </a:spcAft>
+            </a:pPr>
+            <a:r>
+              <a:rPr sz="1300" b="0">
+                <a:solidFill>
+                  <a:srgbClr val="1A1A1A"/>
+                </a:solidFill>
+                <a:latin typeface="Calibri"/>
+                <a:ea typeface="Microsoft YaHei"/>
+                <a:cs typeface="Calibri"/>
+              </a:rPr>
+              <a:t>审稿问：对 DIS/HCI 的贡献是否说清，文献是否站在 HCI，对交互设计的含义是什么。</a:t>
+            </a:r>
+          </a:p>
+          <a:p>
+            <a:pPr algn="l">
+              <a:spcAft>
+                <a:spcPts val="800"/>
+              </a:spcAft>
+            </a:pPr>
+            <a:r>
+              <a:rPr sz="1100" b="0">
+                <a:solidFill>
+                  <a:srgbClr val="555555"/>
+                </a:solidFill>
+                <a:latin typeface="Calibri"/>
+                <a:ea typeface="Microsoft YaHei"/>
+                <a:cs typeface="Calibri"/>
+              </a:rPr>
+              <a:t>Reviewers ask: is the DIS/HCI contribution clear, is it situated in HCI, are implications for interaction design stated?</a:t>
+            </a:r>
+          </a:p>
+          <a:p>
+            <a:pPr algn="l">
+              <a:spcAft>
+                <a:spcPts val="200"/>
+              </a:spcAft>
+            </a:pPr>
+            <a:r>
+              <a:rPr sz="1300" b="0">
+                <a:solidFill>
+                  <a:srgbClr val="1A1A1A"/>
+                </a:solidFill>
+                <a:latin typeface="Calibri"/>
+                <a:ea typeface="Microsoft YaHei"/>
+                <a:cs typeface="Calibri"/>
+              </a:rPr>
+              <a:t>备份：ACM C&amp;C 2027 Papers · 摘要 1月19日 / 全文 1月25日 AoE</a:t>
+            </a:r>
+          </a:p>
+          <a:p>
+            <a:pPr algn="l">
+              <a:spcAft>
+                <a:spcPts val="0"/>
+              </a:spcAft>
+            </a:pPr>
+            <a:r>
+              <a:rPr sz="1100" b="0">
+                <a:solidFill>
+                  <a:srgbClr val="555555"/>
+                </a:solidFill>
+                <a:latin typeface="Calibri"/>
+                <a:ea typeface="Microsoft YaHei"/>
+                <a:cs typeface="Calibri"/>
+              </a:rPr>
+              <a:t>Backup: ACM C&amp;C 2027 Papers · abstract 19 Jan / full paper 25 Jan 2027 AoE</a:t>
+            </a:r>
           </a:p>
         </p:txBody>
       </p:sp>
@@ -2803,19 +3424,22 @@
           <a:bodyPr wrap="square" lIns="0" tIns="0" rIns="0" bIns="0" rtlCol="0" anchor="ctr"/>
           <a:lstStyle/>
           <a:p>
-            <a:pPr indent="0" marL="0">
+            <a:pPr indent="0" marL="0" algn="l">
+              <a:spcAft>
+                <a:spcPts val="0"/>
+              </a:spcAft>
               <a:buNone/>
             </a:pPr>
             <a:r>
-              <a:rPr lang="en-US" sz="1800" b="1" dirty="0">
-                <a:solidFill>
-                  <a:schemeClr val="tx1"/>
-                </a:solidFill>
-                <a:latin typeface="+mj-lt" pitchFamily="34" charset="0"/>
-                <a:ea typeface="+mj-lt" pitchFamily="34" charset="-122"/>
-                <a:cs typeface="+mj-lt" pitchFamily="34" charset="-120"/>
-              </a:rPr>
-              <a:t>By 25 November</a:t>
+              <a:rPr sz="1400" b="1">
+                <a:solidFill>
+                  <a:srgbClr val="1A1A1A"/>
+                </a:solidFill>
+                <a:latin typeface="Calibri"/>
+                <a:ea typeface="Microsoft YaHei"/>
+                <a:cs typeface="Calibri"/>
+              </a:rPr>
+              <a:t>到 11 月 25 日 / By 25 November</a:t>
             </a:r>
             <a:endParaRPr lang="en-US" sz="1800" dirty="0"/>
           </a:p>
@@ -2845,31 +3469,79 @@
           <a:lstStyle/>
           <a:p>
             <a:pPr algn="l" indent="0" marL="0">
+              <a:spcAft>
+                <a:spcPts val="200"/>
+              </a:spcAft>
               <a:buNone/>
             </a:pPr>
             <a:r>
-              <a:rPr lang="en-US" sz="1800" dirty="0">
-                <a:solidFill>
-                  <a:schemeClr val="tx1"/>
-                </a:solidFill>
-              </a:rPr>
-              <a:t>Object: parametric haitang rigid fan. Machine: FDS DZ 13-103 resin (detail) or FDM P2S (iterate). Booking not yet made.</a:t>
+              <a:rPr sz="1300" b="0">
+                <a:solidFill>
+                  <a:srgbClr val="1A1A1A"/>
+                </a:solidFill>
+                <a:latin typeface="Calibri"/>
+                <a:ea typeface="Microsoft YaHei"/>
+                <a:cs typeface="Calibri"/>
+              </a:rPr>
+              <a:t>物件：参数化海棠刚性手扇（不是折扇）。</a:t>
             </a:r>
             <a:endParaRPr lang="en-US" sz="1800" dirty="0"/>
           </a:p>
           <a:p>
             <a:pPr algn="l" indent="0" marL="0">
+              <a:spcAft>
+                <a:spcPts val="600"/>
+              </a:spcAft>
               <a:buNone/>
             </a:pPr>
             <a:r>
-              <a:rPr lang="en-US" sz="1800" dirty="0">
-                <a:solidFill>
-                  <a:schemeClr val="tx1"/>
-                </a:solidFill>
-              </a:rPr>
-              <a:t>Image: process_journal/2026-10-13_haitang-rotating-diamond.png</a:t>
+              <a:rPr sz="1100" b="0">
+                <a:solidFill>
+                  <a:srgbClr val="555555"/>
+                </a:solidFill>
+                <a:latin typeface="Calibri"/>
+                <a:ea typeface="Microsoft YaHei"/>
+                <a:cs typeface="Calibri"/>
+              </a:rPr>
+              <a:t>Object: a parametric haitang rigid hand-fan, not a folding fan.</a:t>
             </a:r>
             <a:endParaRPr lang="en-US" sz="1800" dirty="0"/>
+          </a:p>
+          <a:p>
+            <a:pPr algn="l">
+              <a:spcAft>
+                <a:spcPts val="200"/>
+              </a:spcAft>
+            </a:pPr>
+            <a:r>
+              <a:rPr sz="1300" b="0">
+                <a:solidFill>
+                  <a:srgbClr val="1A1A1A"/>
+                </a:solidFill>
+                <a:latin typeface="Calibri"/>
+                <a:ea typeface="Microsoft YaHei"/>
+                <a:cs typeface="Calibri"/>
+              </a:rPr>
+              <a:t>机器：FDS DZ 13-103，细密用树脂，迭代用 FDM P2S。预约未做。</a:t>
+            </a:r>
+          </a:p>
+          <a:p>
+            <a:pPr algn="l">
+              <a:spcAft>
+                <a:spcPts val="0"/>
+              </a:spcAft>
+            </a:pPr>
+            <a:r>
+              <a:rPr sz="1100" b="0">
+                <a:solidFill>
+                  <a:srgbClr val="555555"/>
+                </a:solidFill>
+                <a:latin typeface="Calibri"/>
+                <a:ea typeface="Microsoft YaHei"/>
+                <a:cs typeface="Calibri"/>
+              </a:rPr>
+              <a:t>Machine: FDS DZ 13-103; resin for fine weave, FDM P2S to iterate. Not yet booked.</a:t>
+            </a:r>
           </a:p>
         </p:txBody>
       </p:sp>
@@ -2918,6 +3590,30 @@
           </a:p>
         </p:txBody>
       </p:sp>
+      <p:pic>
+        <p:nvPicPr>
+          <p:cNvPr id="26" name="Picture 25" descr="2026-10-13_haitang-rotating-diamond.png"/>
+          <p:cNvPicPr>
+            <a:picLocks noChangeAspect="1"/>
+          </p:cNvPicPr>
+          <p:nvPr/>
+        </p:nvPicPr>
+        <p:blipFill>
+          <a:blip r:embed="rId3"/>
+          <a:stretch>
+            <a:fillRect/>
+          </a:stretch>
+        </p:blipFill>
+        <p:spPr>
+          <a:xfrm>
+            <a:off x="7985760" y="4300000"/>
+            <a:ext cx="3276600" cy="1900000"/>
+          </a:xfrm>
+          <a:prstGeom prst="rect">
+            <a:avLst/>
+          </a:prstGeom>
+        </p:spPr>
+      </p:pic>
     </p:spTree>
   </p:cSld>
   <p:clrMapOvr>

</xml_diff>